<commit_message>
új kép a ppt-ben
</commit_message>
<xml_diff>
--- a/Szakma bemutató.pptx
+++ b/Szakma bemutató.pptx
@@ -4330,10 +4330,10 @@
       </p:sp>
       <p:pic>
         <p:nvPicPr>
-          <p:cNvPr id="7" name="Kép 6">
-            <a:extLst>
-              <a:ext uri="{FF2B5EF4-FFF2-40B4-BE49-F238E27FC236}">
-                <a16:creationId xmlns:a16="http://schemas.microsoft.com/office/drawing/2014/main" id="{9A09C154-EC18-4537-AEFB-AFA85C41F54C}"/>
+          <p:cNvPr id="6" name="Kép 5">
+            <a:extLst>
+              <a:ext uri="{FF2B5EF4-FFF2-40B4-BE49-F238E27FC236}">
+                <a16:creationId xmlns:a16="http://schemas.microsoft.com/office/drawing/2014/main" id="{18C5F0B1-4182-4E60-ABE9-2A4810026AD5}"/>
               </a:ext>
             </a:extLst>
           </p:cNvPr>
@@ -4350,8 +4350,8 @@
         </p:blipFill>
         <p:spPr>
           <a:xfrm>
-            <a:off x="6096000" y="1696760"/>
-            <a:ext cx="6095999" cy="2494551"/>
+            <a:off x="5954013" y="1669624"/>
+            <a:ext cx="6255812" cy="2624470"/>
           </a:xfrm>
           <a:prstGeom prst="rect">
             <a:avLst/>

</xml_diff>